<commit_message>
Add customer centricity as fourth lesson in GoFar deck
Co-Authored-By: Claude Opus 5.5 <noreply@anthropic.com>
Claude-Session: https://claude.ai/code/session_01XnECCStxZTRunjSaWV1VGN
</commit_message>
<xml_diff>
--- a/deck/GoFar_Support_Deck.pptx
+++ b/deck/GoFar_Support_Deck.pptx
@@ -116,30 +116,30 @@
   <p:extLst>
     <p:ext uri="{521415D9-36F7-43E2-AB2F-B90AF26B5E84}">
       <p14:sectionLst xmlns:p14="http://schemas.microsoft.com/office/powerpoint/2010/main">
-        <p14:section name="Overview" id="{ee248eaf-e4a4-e1c9-05f7-ae188bf0156a}">
+        <p14:section name="Overview" id="{0d39410e-c938-783e-29ac-c54a43206629}">
           <p14:sldIdLst>
             <p14:sldId id="256"/>
             <p14:sldId id="257"/>
             <p14:sldId id="258"/>
           </p14:sldIdLst>
         </p14:section>
-        <p14:section name="C&amp;V Phase" id="{f316964b-22eb-c004-b9cf-3112dbcaa05f}">
+        <p14:section name="C&amp;V Phase" id="{7c001eaa-dbbc-b892-ac76-a75399d4669a}">
           <p14:sldIdLst>
             <p14:sldId id="259"/>
             <p14:sldId id="260"/>
           </p14:sldIdLst>
         </p14:section>
-        <p14:section name="Pre-ECI" id="{f3aed514-409a-257c-92c8-fd88c4b1092a}">
+        <p14:section name="Pre-ECI" id="{74bf4150-d82c-3462-9ad0-3d9a26168efb}">
           <p14:sldIdLst>
             <p14:sldId id="261"/>
           </p14:sldIdLst>
         </p14:section>
-        <p14:section name="ECI Phase" id="{4327ef5e-5260-9c4c-421d-46d8a34e45b8}">
+        <p14:section name="ECI Phase" id="{9a730e77-944c-8029-676d-00fb7db84be5}">
           <p14:sldIdLst>
             <p14:sldId id="262"/>
           </p14:sldIdLst>
         </p14:section>
-        <p14:section name="Reflections" id="{f66cde2f-ddca-4b29-5f6f-3b7ef2667552}">
+        <p14:section name="Reflections" id="{5b93d928-e5f6-fa33-58c1-f62baebe5d79}">
           <p14:sldIdLst>
             <p14:sldId id="263"/>
             <p14:sldId id="264"/>
@@ -1254,7 +1254,7 @@
           <a:p>
             <a:r>
               <a:rPr lang="en-US" dirty="0"/>
-              <a:t>Lesson 1: in the 13 October session, a GoFar team member noted they knew far more than they would have without preparing. Lesson 2: after the 15 October Fire and Life Safety workshop, the team reported HSRA used GoFar's slides as the agenda. Lesson 3: the 6 October debrief noted GoFar built on HSRA's own work, while John Holland Acciona floated a late idea that went nowhere.</a:t>
+              <a:t>Lesson 1: in the 13 October session, a GoFar team member noted they knew far more than they would have without preparing. Lesson 2: after the 15 October Fire and Life Safety workshop, the team reported HSRA used GoFar's slides as the agenda. Lesson 3: the 6 October debrief noted GoFar built on HSRA's own work, while John Holland Acciona floated a late idea that went nowhere. Lesson 4: customer centricity is the thread through all three. The 6 October debrief noted the team linked each point to the benefit for HSRA, and Gamuda Samsung called it the GoFar alignment. Putting HSRA at the centre of every message is what sets GoFar apart, and the December Customer Centricity Coaching workshop will build on it.</a:t>
             </a:r>
             <a:endParaRPr lang="en-US" dirty="0"/>
           </a:p>
@@ -13081,7 +13081,7 @@
                   <a:schemeClr val="tx1"/>
                 </a:solidFill>
               </a:rPr>
-              <a:t>Three lessons from the C&amp;V Phase</a:t>
+              <a:t>Four lessons from the C&amp;V Phase</a:t>
             </a:r>
             <a:endParaRPr lang="en-US" sz="2800" dirty="0"/>
           </a:p>
@@ -13089,122 +13089,14 @@
       </p:sp>
       <p:sp>
         <p:nvSpPr>
-          <p:cNvPr id="4" name="Text 2"/>
-          <p:cNvSpPr txBox="1"/>
-          <p:nvPr/>
-        </p:nvSpPr>
-        <p:spPr>
-          <a:xfrm>
-            <a:off x="548640" y="1508760"/>
-            <a:ext cx="3484778" cy="731520"/>
-          </a:xfrm>
-          <a:prstGeom prst="rect">
-            <a:avLst/>
-          </a:prstGeom>
-          <a:noFill/>
-          <a:ln/>
-        </p:spPr>
-        <p:txBody>
-          <a:bodyPr wrap="square" lIns="0" tIns="0" rIns="0" bIns="0" rtlCol="0" anchor="ctr"/>
-          <a:lstStyle/>
-          <a:p>
-            <a:pPr indent="0" marL="0">
-              <a:buNone/>
-            </a:pPr>
-            <a:r>
-              <a:rPr lang="en-US" sz="4400" b="1" dirty="0">
-                <a:solidFill>
-                  <a:srgbClr val="F48047"/>
-                </a:solidFill>
-              </a:rPr>
-              <a:t>01</a:t>
-            </a:r>
-            <a:endParaRPr lang="en-US" sz="4400" dirty="0"/>
-          </a:p>
-        </p:txBody>
-      </p:sp>
-      <p:sp>
-        <p:nvSpPr>
-          <p:cNvPr id="5" name="Text 3"/>
-          <p:cNvSpPr txBox="1"/>
-          <p:nvPr/>
-        </p:nvSpPr>
-        <p:spPr>
-          <a:xfrm>
-            <a:off x="548640" y="2286000"/>
-            <a:ext cx="3484778" cy="731520"/>
-          </a:xfrm>
-          <a:prstGeom prst="rect">
-            <a:avLst/>
-          </a:prstGeom>
-          <a:noFill/>
-          <a:ln/>
-        </p:spPr>
-        <p:txBody>
-          <a:bodyPr wrap="square" lIns="0" tIns="0" rIns="0" bIns="0" rtlCol="0" anchor="t"/>
-          <a:lstStyle/>
-          <a:p>
-            <a:pPr indent="0" marL="0">
-              <a:buNone/>
-            </a:pPr>
-            <a:r>
-              <a:rPr lang="en-US" sz="1800" b="1" dirty="0">
-                <a:solidFill>
-                  <a:srgbClr val="3D3C3C"/>
-                </a:solidFill>
-              </a:rPr>
-              <a:t>Preparation is paramount</a:t>
-            </a:r>
-            <a:endParaRPr lang="en-US" sz="1800" dirty="0"/>
-          </a:p>
-        </p:txBody>
-      </p:sp>
-      <p:sp>
-        <p:nvSpPr>
-          <p:cNvPr id="6" name="Text 4"/>
-          <p:cNvSpPr txBox="1"/>
-          <p:nvPr/>
-        </p:nvSpPr>
-        <p:spPr>
-          <a:xfrm>
-            <a:off x="548640" y="3017520"/>
-            <a:ext cx="3484778" cy="1188720"/>
-          </a:xfrm>
-          <a:prstGeom prst="rect">
-            <a:avLst/>
-          </a:prstGeom>
-          <a:noFill/>
-          <a:ln/>
-        </p:spPr>
-        <p:txBody>
-          <a:bodyPr wrap="square" lIns="0" tIns="0" rIns="0" bIns="0" rtlCol="0" anchor="t"/>
-          <a:lstStyle/>
-          <a:p>
-            <a:pPr indent="0" marL="0">
-              <a:buNone/>
-            </a:pPr>
-            <a:r>
-              <a:rPr lang="en-US" sz="1250" dirty="0">
-                <a:solidFill>
-                  <a:srgbClr val="3D3C3C"/>
-                </a:solidFill>
-              </a:rPr>
-              <a:t>Thorough preparation gives the team its key messages and puts GoFar in a strong light, even when slides are not presented.</a:t>
-            </a:r>
-            <a:endParaRPr lang="en-US" sz="1250" dirty="0"/>
-          </a:p>
-        </p:txBody>
-      </p:sp>
-      <p:sp>
-        <p:nvSpPr>
-          <p:cNvPr id="7" name="Shape 5"/>
+          <p:cNvPr id="4" name="Shape 2"/>
           <p:cNvSpPr/>
           <p:nvPr/>
         </p:nvSpPr>
         <p:spPr>
           <a:xfrm>
-            <a:off x="548640" y="4343400"/>
-            <a:ext cx="3484778" cy="1645920"/>
+            <a:off x="548640" y="1463040"/>
+            <a:ext cx="5387188" cy="2148840"/>
           </a:xfrm>
           <a:prstGeom prst="rect">
             <a:avLst/>
@@ -13222,14 +13114,122 @@
       </p:sp>
       <p:sp>
         <p:nvSpPr>
+          <p:cNvPr id="5" name="Text 3"/>
+          <p:cNvSpPr txBox="1"/>
+          <p:nvPr/>
+        </p:nvSpPr>
+        <p:spPr>
+          <a:xfrm>
+            <a:off x="822960" y="1645920"/>
+            <a:ext cx="640080" cy="548640"/>
+          </a:xfrm>
+          <a:prstGeom prst="rect">
+            <a:avLst/>
+          </a:prstGeom>
+          <a:noFill/>
+          <a:ln/>
+        </p:spPr>
+        <p:txBody>
+          <a:bodyPr wrap="square" lIns="0" tIns="0" rIns="0" bIns="0" rtlCol="0" anchor="ctr"/>
+          <a:lstStyle/>
+          <a:p>
+            <a:pPr indent="0" marL="0">
+              <a:buNone/>
+            </a:pPr>
+            <a:r>
+              <a:rPr lang="en-US" sz="2800" b="1" dirty="0">
+                <a:solidFill>
+                  <a:srgbClr val="F48047"/>
+                </a:solidFill>
+              </a:rPr>
+              <a:t>01</a:t>
+            </a:r>
+            <a:endParaRPr lang="en-US" sz="2800" dirty="0"/>
+          </a:p>
+        </p:txBody>
+      </p:sp>
+      <p:sp>
+        <p:nvSpPr>
+          <p:cNvPr id="6" name="Text 4"/>
+          <p:cNvSpPr txBox="1"/>
+          <p:nvPr/>
+        </p:nvSpPr>
+        <p:spPr>
+          <a:xfrm>
+            <a:off x="1444752" y="1645920"/>
+            <a:ext cx="4244188" cy="548640"/>
+          </a:xfrm>
+          <a:prstGeom prst="rect">
+            <a:avLst/>
+          </a:prstGeom>
+          <a:noFill/>
+          <a:ln/>
+        </p:spPr>
+        <p:txBody>
+          <a:bodyPr wrap="square" lIns="0" tIns="0" rIns="0" bIns="0" rtlCol="0" anchor="ctr"/>
+          <a:lstStyle/>
+          <a:p>
+            <a:pPr indent="0" marL="0">
+              <a:buNone/>
+            </a:pPr>
+            <a:r>
+              <a:rPr lang="en-US" sz="1600" b="1" dirty="0">
+                <a:solidFill>
+                  <a:srgbClr val="3D3C3C"/>
+                </a:solidFill>
+              </a:rPr>
+              <a:t>Preparation is paramount</a:t>
+            </a:r>
+            <a:endParaRPr lang="en-US" sz="1600" dirty="0"/>
+          </a:p>
+        </p:txBody>
+      </p:sp>
+      <p:sp>
+        <p:nvSpPr>
+          <p:cNvPr id="7" name="Text 5"/>
+          <p:cNvSpPr txBox="1"/>
+          <p:nvPr/>
+        </p:nvSpPr>
+        <p:spPr>
+          <a:xfrm>
+            <a:off x="822960" y="2267712"/>
+            <a:ext cx="4838548" cy="640080"/>
+          </a:xfrm>
+          <a:prstGeom prst="rect">
+            <a:avLst/>
+          </a:prstGeom>
+          <a:noFill/>
+          <a:ln/>
+        </p:spPr>
+        <p:txBody>
+          <a:bodyPr wrap="square" lIns="0" tIns="0" rIns="0" bIns="0" rtlCol="0" anchor="t"/>
+          <a:lstStyle/>
+          <a:p>
+            <a:pPr indent="0" marL="0">
+              <a:buNone/>
+            </a:pPr>
+            <a:r>
+              <a:rPr lang="en-US" sz="1200" dirty="0">
+                <a:solidFill>
+                  <a:srgbClr val="3D3C3C"/>
+                </a:solidFill>
+              </a:rPr>
+              <a:t>Thorough preparation gives the team its key messages and puts GoFar in a strong light, even when slides are not presented.</a:t>
+            </a:r>
+            <a:endParaRPr lang="en-US" sz="1200" dirty="0"/>
+          </a:p>
+        </p:txBody>
+      </p:sp>
+      <p:sp>
+        <p:nvSpPr>
           <p:cNvPr id="8" name="Text 6"/>
           <p:cNvSpPr txBox="1"/>
           <p:nvPr/>
         </p:nvSpPr>
         <p:spPr>
           <a:xfrm>
-            <a:off x="777240" y="4480560"/>
-            <a:ext cx="3027578" cy="1417320"/>
+            <a:off x="822960" y="2926080"/>
+            <a:ext cx="4838548" cy="566928"/>
           </a:xfrm>
           <a:prstGeom prst="rect">
             <a:avLst/>
@@ -13245,149 +13245,38 @@
               <a:buNone/>
             </a:pPr>
             <a:r>
-              <a:rPr lang="en-US" sz="1000" b="1" spc="150" kern="0" dirty="0">
+              <a:rPr lang="en-US" sz="1100" b="1" i="1" dirty="0">
                 <a:solidFill>
                   <a:srgbClr val="F48047"/>
                 </a:solidFill>
               </a:rPr>
-              <a:t>IN PRACTICE</a:t>
-            </a:r>
-            <a:endParaRPr lang="en-US" sz="1000" dirty="0"/>
-          </a:p>
-          <a:p>
+              <a:t>In practice:  </a:t>
+            </a:r>
             <a:pPr indent="0" marL="0">
               <a:buNone/>
             </a:pPr>
             <a:r>
-              <a:rPr lang="en-US" sz="1200" dirty="0">
+              <a:rPr lang="en-US" sz="1100" i="1" dirty="0">
                 <a:solidFill>
                   <a:srgbClr val="3D3C3C"/>
                 </a:solidFill>
               </a:rPr>
               <a:t>On 13 October, GoFar was not asked to present, yet the team was better informed and ready because of the work done beforehand.</a:t>
             </a:r>
-            <a:endParaRPr lang="en-US" sz="1000" dirty="0"/>
-          </a:p>
-        </p:txBody>
-      </p:sp>
-      <p:sp>
-        <p:nvSpPr>
-          <p:cNvPr id="9" name="Text 7"/>
-          <p:cNvSpPr txBox="1"/>
-          <p:nvPr/>
-        </p:nvSpPr>
-        <p:spPr>
-          <a:xfrm>
-            <a:off x="4353458" y="1508760"/>
-            <a:ext cx="3484778" cy="731520"/>
-          </a:xfrm>
-          <a:prstGeom prst="rect">
-            <a:avLst/>
-          </a:prstGeom>
-          <a:noFill/>
-          <a:ln/>
-        </p:spPr>
-        <p:txBody>
-          <a:bodyPr wrap="square" lIns="0" tIns="0" rIns="0" bIns="0" rtlCol="0" anchor="ctr"/>
-          <a:lstStyle/>
-          <a:p>
-            <a:pPr indent="0" marL="0">
-              <a:buNone/>
-            </a:pPr>
-            <a:r>
-              <a:rPr lang="en-US" sz="4400" b="1" dirty="0">
-                <a:solidFill>
-                  <a:srgbClr val="0E98D7"/>
-                </a:solidFill>
-              </a:rPr>
-              <a:t>02</a:t>
-            </a:r>
-            <a:endParaRPr lang="en-US" sz="4400" dirty="0"/>
-          </a:p>
-        </p:txBody>
-      </p:sp>
-      <p:sp>
-        <p:nvSpPr>
-          <p:cNvPr id="10" name="Text 8"/>
-          <p:cNvSpPr txBox="1"/>
-          <p:nvPr/>
-        </p:nvSpPr>
-        <p:spPr>
-          <a:xfrm>
-            <a:off x="4353458" y="2286000"/>
-            <a:ext cx="3484778" cy="731520"/>
-          </a:xfrm>
-          <a:prstGeom prst="rect">
-            <a:avLst/>
-          </a:prstGeom>
-          <a:noFill/>
-          <a:ln/>
-        </p:spPr>
-        <p:txBody>
-          <a:bodyPr wrap="square" lIns="0" tIns="0" rIns="0" bIns="0" rtlCol="0" anchor="t"/>
-          <a:lstStyle/>
-          <a:p>
-            <a:pPr indent="0" marL="0">
-              <a:buNone/>
-            </a:pPr>
-            <a:r>
-              <a:rPr lang="en-US" sz="1800" b="1" dirty="0">
-                <a:solidFill>
-                  <a:srgbClr val="3D3C3C"/>
-                </a:solidFill>
-              </a:rPr>
-              <a:t>HSRA values guidance and capability</a:t>
-            </a:r>
-            <a:endParaRPr lang="en-US" sz="1800" dirty="0"/>
-          </a:p>
-        </p:txBody>
-      </p:sp>
-      <p:sp>
-        <p:nvSpPr>
-          <p:cNvPr id="11" name="Text 9"/>
-          <p:cNvSpPr txBox="1"/>
-          <p:nvPr/>
-        </p:nvSpPr>
-        <p:spPr>
-          <a:xfrm>
-            <a:off x="4353458" y="3017520"/>
-            <a:ext cx="3484778" cy="1188720"/>
-          </a:xfrm>
-          <a:prstGeom prst="rect">
-            <a:avLst/>
-          </a:prstGeom>
-          <a:noFill/>
-          <a:ln/>
-        </p:spPr>
-        <p:txBody>
-          <a:bodyPr wrap="square" lIns="0" tIns="0" rIns="0" bIns="0" rtlCol="0" anchor="t"/>
-          <a:lstStyle/>
-          <a:p>
-            <a:pPr indent="0" marL="0">
-              <a:buNone/>
-            </a:pPr>
-            <a:r>
-              <a:rPr lang="en-US" sz="1250" dirty="0">
-                <a:solidFill>
-                  <a:srgbClr val="3D3C3C"/>
-                </a:solidFill>
-              </a:rPr>
-              <a:t>HSRA is looking for as much guidance as possible and responds to partners who bring structure and clarity.</a:t>
-            </a:r>
-            <a:endParaRPr lang="en-US" sz="1250" dirty="0"/>
-          </a:p>
-        </p:txBody>
-      </p:sp>
-      <p:sp>
-        <p:nvSpPr>
-          <p:cNvPr id="12" name="Shape 10"/>
+            <a:endParaRPr lang="en-US" sz="1100" dirty="0"/>
+          </a:p>
+        </p:txBody>
+      </p:sp>
+      <p:sp>
+        <p:nvSpPr>
+          <p:cNvPr id="9" name="Shape 7"/>
           <p:cNvSpPr/>
           <p:nvPr/>
         </p:nvSpPr>
         <p:spPr>
           <a:xfrm>
-            <a:off x="4353458" y="4343400"/>
-            <a:ext cx="3484778" cy="1645920"/>
+            <a:off x="6255868" y="1463040"/>
+            <a:ext cx="5387188" cy="2148840"/>
           </a:xfrm>
           <a:prstGeom prst="rect">
             <a:avLst/>
@@ -13405,14 +13294,122 @@
       </p:sp>
       <p:sp>
         <p:nvSpPr>
+          <p:cNvPr id="10" name="Text 8"/>
+          <p:cNvSpPr txBox="1"/>
+          <p:nvPr/>
+        </p:nvSpPr>
+        <p:spPr>
+          <a:xfrm>
+            <a:off x="6530188" y="1645920"/>
+            <a:ext cx="640080" cy="548640"/>
+          </a:xfrm>
+          <a:prstGeom prst="rect">
+            <a:avLst/>
+          </a:prstGeom>
+          <a:noFill/>
+          <a:ln/>
+        </p:spPr>
+        <p:txBody>
+          <a:bodyPr wrap="square" lIns="0" tIns="0" rIns="0" bIns="0" rtlCol="0" anchor="ctr"/>
+          <a:lstStyle/>
+          <a:p>
+            <a:pPr indent="0" marL="0">
+              <a:buNone/>
+            </a:pPr>
+            <a:r>
+              <a:rPr lang="en-US" sz="2800" b="1" dirty="0">
+                <a:solidFill>
+                  <a:srgbClr val="0E98D7"/>
+                </a:solidFill>
+              </a:rPr>
+              <a:t>02</a:t>
+            </a:r>
+            <a:endParaRPr lang="en-US" sz="2800" dirty="0"/>
+          </a:p>
+        </p:txBody>
+      </p:sp>
+      <p:sp>
+        <p:nvSpPr>
+          <p:cNvPr id="11" name="Text 9"/>
+          <p:cNvSpPr txBox="1"/>
+          <p:nvPr/>
+        </p:nvSpPr>
+        <p:spPr>
+          <a:xfrm>
+            <a:off x="7151980" y="1645920"/>
+            <a:ext cx="4244188" cy="548640"/>
+          </a:xfrm>
+          <a:prstGeom prst="rect">
+            <a:avLst/>
+          </a:prstGeom>
+          <a:noFill/>
+          <a:ln/>
+        </p:spPr>
+        <p:txBody>
+          <a:bodyPr wrap="square" lIns="0" tIns="0" rIns="0" bIns="0" rtlCol="0" anchor="ctr"/>
+          <a:lstStyle/>
+          <a:p>
+            <a:pPr indent="0" marL="0">
+              <a:buNone/>
+            </a:pPr>
+            <a:r>
+              <a:rPr lang="en-US" sz="1600" b="1" dirty="0">
+                <a:solidFill>
+                  <a:srgbClr val="3D3C3C"/>
+                </a:solidFill>
+              </a:rPr>
+              <a:t>HSRA values guidance and capability</a:t>
+            </a:r>
+            <a:endParaRPr lang="en-US" sz="1600" dirty="0"/>
+          </a:p>
+        </p:txBody>
+      </p:sp>
+      <p:sp>
+        <p:nvSpPr>
+          <p:cNvPr id="12" name="Text 10"/>
+          <p:cNvSpPr txBox="1"/>
+          <p:nvPr/>
+        </p:nvSpPr>
+        <p:spPr>
+          <a:xfrm>
+            <a:off x="6530188" y="2267712"/>
+            <a:ext cx="4838548" cy="640080"/>
+          </a:xfrm>
+          <a:prstGeom prst="rect">
+            <a:avLst/>
+          </a:prstGeom>
+          <a:noFill/>
+          <a:ln/>
+        </p:spPr>
+        <p:txBody>
+          <a:bodyPr wrap="square" lIns="0" tIns="0" rIns="0" bIns="0" rtlCol="0" anchor="t"/>
+          <a:lstStyle/>
+          <a:p>
+            <a:pPr indent="0" marL="0">
+              <a:buNone/>
+            </a:pPr>
+            <a:r>
+              <a:rPr lang="en-US" sz="1200" dirty="0">
+                <a:solidFill>
+                  <a:srgbClr val="3D3C3C"/>
+                </a:solidFill>
+              </a:rPr>
+              <a:t>HSRA is looking for as much guidance as possible and responds to partners who bring structure and clarity.</a:t>
+            </a:r>
+            <a:endParaRPr lang="en-US" sz="1200" dirty="0"/>
+          </a:p>
+        </p:txBody>
+      </p:sp>
+      <p:sp>
+        <p:nvSpPr>
           <p:cNvPr id="13" name="Text 11"/>
           <p:cNvSpPr txBox="1"/>
           <p:nvPr/>
         </p:nvSpPr>
         <p:spPr>
           <a:xfrm>
-            <a:off x="4582058" y="4480560"/>
-            <a:ext cx="3027578" cy="1417320"/>
+            <a:off x="6530188" y="2926080"/>
+            <a:ext cx="4838548" cy="566928"/>
           </a:xfrm>
           <a:prstGeom prst="rect">
             <a:avLst/>
@@ -13428,149 +13425,38 @@
               <a:buNone/>
             </a:pPr>
             <a:r>
-              <a:rPr lang="en-US" sz="1000" b="1" spc="150" kern="0" dirty="0">
+              <a:rPr lang="en-US" sz="1100" b="1" i="1" dirty="0">
                 <a:solidFill>
                   <a:srgbClr val="0E98D7"/>
                 </a:solidFill>
               </a:rPr>
-              <a:t>IN PRACTICE</a:t>
-            </a:r>
-            <a:endParaRPr lang="en-US" sz="1000" dirty="0"/>
-          </a:p>
-          <a:p>
+              <a:t>In practice:  </a:t>
+            </a:r>
             <a:pPr indent="0" marL="0">
               <a:buNone/>
             </a:pPr>
             <a:r>
-              <a:rPr lang="en-US" sz="1200" dirty="0">
+              <a:rPr lang="en-US" sz="1100" i="1" dirty="0">
                 <a:solidFill>
                   <a:srgbClr val="3D3C3C"/>
                 </a:solidFill>
               </a:rPr>
               <a:t>In the Fire and Life Safety workshop, HSRA used GoFar's slides to run the meeting, as they covered every point on its agenda.</a:t>
             </a:r>
-            <a:endParaRPr lang="en-US" sz="1000" dirty="0"/>
-          </a:p>
-        </p:txBody>
-      </p:sp>
-      <p:sp>
-        <p:nvSpPr>
-          <p:cNvPr id="14" name="Text 12"/>
-          <p:cNvSpPr txBox="1"/>
-          <p:nvPr/>
-        </p:nvSpPr>
-        <p:spPr>
-          <a:xfrm>
-            <a:off x="8158277" y="1508760"/>
-            <a:ext cx="3484778" cy="731520"/>
-          </a:xfrm>
-          <a:prstGeom prst="rect">
-            <a:avLst/>
-          </a:prstGeom>
-          <a:noFill/>
-          <a:ln/>
-        </p:spPr>
-        <p:txBody>
-          <a:bodyPr wrap="square" lIns="0" tIns="0" rIns="0" bIns="0" rtlCol="0" anchor="ctr"/>
-          <a:lstStyle/>
-          <a:p>
-            <a:pPr indent="0" marL="0">
-              <a:buNone/>
-            </a:pPr>
-            <a:r>
-              <a:rPr lang="en-US" sz="4400" b="1" dirty="0">
-                <a:solidFill>
-                  <a:srgbClr val="EE2B7A"/>
-                </a:solidFill>
-              </a:rPr>
-              <a:t>03</a:t>
-            </a:r>
-            <a:endParaRPr lang="en-US" sz="4400" dirty="0"/>
-          </a:p>
-        </p:txBody>
-      </p:sp>
-      <p:sp>
-        <p:nvSpPr>
-          <p:cNvPr id="15" name="Text 13"/>
-          <p:cNvSpPr txBox="1"/>
-          <p:nvPr/>
-        </p:nvSpPr>
-        <p:spPr>
-          <a:xfrm>
-            <a:off x="8158277" y="2286000"/>
-            <a:ext cx="3484778" cy="731520"/>
-          </a:xfrm>
-          <a:prstGeom prst="rect">
-            <a:avLst/>
-          </a:prstGeom>
-          <a:noFill/>
-          <a:ln/>
-        </p:spPr>
-        <p:txBody>
-          <a:bodyPr wrap="square" lIns="0" tIns="0" rIns="0" bIns="0" rtlCol="0" anchor="t"/>
-          <a:lstStyle/>
-          <a:p>
-            <a:pPr indent="0" marL="0">
-              <a:buNone/>
-            </a:pPr>
-            <a:r>
-              <a:rPr lang="en-US" sz="1800" b="1" dirty="0">
-                <a:solidFill>
-                  <a:srgbClr val="3D3C3C"/>
-                </a:solidFill>
-              </a:rPr>
-              <a:t>Listening builds credibility</a:t>
-            </a:r>
-            <a:endParaRPr lang="en-US" sz="1800" dirty="0"/>
-          </a:p>
-        </p:txBody>
-      </p:sp>
-      <p:sp>
-        <p:nvSpPr>
-          <p:cNvPr id="16" name="Text 14"/>
-          <p:cNvSpPr txBox="1"/>
-          <p:nvPr/>
-        </p:nvSpPr>
-        <p:spPr>
-          <a:xfrm>
-            <a:off x="8158277" y="3017520"/>
-            <a:ext cx="3484778" cy="1188720"/>
-          </a:xfrm>
-          <a:prstGeom prst="rect">
-            <a:avLst/>
-          </a:prstGeom>
-          <a:noFill/>
-          <a:ln/>
-        </p:spPr>
-        <p:txBody>
-          <a:bodyPr wrap="square" lIns="0" tIns="0" rIns="0" bIns="0" rtlCol="0" anchor="t"/>
-          <a:lstStyle/>
-          <a:p>
-            <a:pPr indent="0" marL="0">
-              <a:buNone/>
-            </a:pPr>
-            <a:r>
-              <a:rPr lang="en-US" sz="1250" dirty="0">
-                <a:solidFill>
-                  <a:srgbClr val="3D3C3C"/>
-                </a:solidFill>
-              </a:rPr>
-              <a:t>Responding to what HSRA has asked for, and building on its own work, earns more trust than innovation for its own sake.</a:t>
-            </a:r>
-            <a:endParaRPr lang="en-US" sz="1250" dirty="0"/>
-          </a:p>
-        </p:txBody>
-      </p:sp>
-      <p:sp>
-        <p:nvSpPr>
-          <p:cNvPr id="17" name="Shape 15"/>
+            <a:endParaRPr lang="en-US" sz="1100" dirty="0"/>
+          </a:p>
+        </p:txBody>
+      </p:sp>
+      <p:sp>
+        <p:nvSpPr>
+          <p:cNvPr id="14" name="Shape 12"/>
           <p:cNvSpPr/>
           <p:nvPr/>
         </p:nvSpPr>
         <p:spPr>
           <a:xfrm>
-            <a:off x="8158277" y="4343400"/>
-            <a:ext cx="3484778" cy="1645920"/>
+            <a:off x="548640" y="3886200"/>
+            <a:ext cx="5387188" cy="2148840"/>
           </a:xfrm>
           <a:prstGeom prst="rect">
             <a:avLst/>
@@ -13588,14 +13474,122 @@
       </p:sp>
       <p:sp>
         <p:nvSpPr>
+          <p:cNvPr id="15" name="Text 13"/>
+          <p:cNvSpPr txBox="1"/>
+          <p:nvPr/>
+        </p:nvSpPr>
+        <p:spPr>
+          <a:xfrm>
+            <a:off x="822960" y="4069080"/>
+            <a:ext cx="640080" cy="548640"/>
+          </a:xfrm>
+          <a:prstGeom prst="rect">
+            <a:avLst/>
+          </a:prstGeom>
+          <a:noFill/>
+          <a:ln/>
+        </p:spPr>
+        <p:txBody>
+          <a:bodyPr wrap="square" lIns="0" tIns="0" rIns="0" bIns="0" rtlCol="0" anchor="ctr"/>
+          <a:lstStyle/>
+          <a:p>
+            <a:pPr indent="0" marL="0">
+              <a:buNone/>
+            </a:pPr>
+            <a:r>
+              <a:rPr lang="en-US" sz="2800" b="1" dirty="0">
+                <a:solidFill>
+                  <a:srgbClr val="EE2B7A"/>
+                </a:solidFill>
+              </a:rPr>
+              <a:t>03</a:t>
+            </a:r>
+            <a:endParaRPr lang="en-US" sz="2800" dirty="0"/>
+          </a:p>
+        </p:txBody>
+      </p:sp>
+      <p:sp>
+        <p:nvSpPr>
+          <p:cNvPr id="16" name="Text 14"/>
+          <p:cNvSpPr txBox="1"/>
+          <p:nvPr/>
+        </p:nvSpPr>
+        <p:spPr>
+          <a:xfrm>
+            <a:off x="1444752" y="4069080"/>
+            <a:ext cx="4244188" cy="548640"/>
+          </a:xfrm>
+          <a:prstGeom prst="rect">
+            <a:avLst/>
+          </a:prstGeom>
+          <a:noFill/>
+          <a:ln/>
+        </p:spPr>
+        <p:txBody>
+          <a:bodyPr wrap="square" lIns="0" tIns="0" rIns="0" bIns="0" rtlCol="0" anchor="ctr"/>
+          <a:lstStyle/>
+          <a:p>
+            <a:pPr indent="0" marL="0">
+              <a:buNone/>
+            </a:pPr>
+            <a:r>
+              <a:rPr lang="en-US" sz="1600" b="1" dirty="0">
+                <a:solidFill>
+                  <a:srgbClr val="3D3C3C"/>
+                </a:solidFill>
+              </a:rPr>
+              <a:t>Listening builds credibility</a:t>
+            </a:r>
+            <a:endParaRPr lang="en-US" sz="1600" dirty="0"/>
+          </a:p>
+        </p:txBody>
+      </p:sp>
+      <p:sp>
+        <p:nvSpPr>
+          <p:cNvPr id="17" name="Text 15"/>
+          <p:cNvSpPr txBox="1"/>
+          <p:nvPr/>
+        </p:nvSpPr>
+        <p:spPr>
+          <a:xfrm>
+            <a:off x="822960" y="4690872"/>
+            <a:ext cx="4838548" cy="640080"/>
+          </a:xfrm>
+          <a:prstGeom prst="rect">
+            <a:avLst/>
+          </a:prstGeom>
+          <a:noFill/>
+          <a:ln/>
+        </p:spPr>
+        <p:txBody>
+          <a:bodyPr wrap="square" lIns="0" tIns="0" rIns="0" bIns="0" rtlCol="0" anchor="t"/>
+          <a:lstStyle/>
+          <a:p>
+            <a:pPr indent="0" marL="0">
+              <a:buNone/>
+            </a:pPr>
+            <a:r>
+              <a:rPr lang="en-US" sz="1200" dirty="0">
+                <a:solidFill>
+                  <a:srgbClr val="3D3C3C"/>
+                </a:solidFill>
+              </a:rPr>
+              <a:t>Responding to what HSRA has asked for, and building on its own work, earns more trust than innovation for its own sake.</a:t>
+            </a:r>
+            <a:endParaRPr lang="en-US" sz="1200" dirty="0"/>
+          </a:p>
+        </p:txBody>
+      </p:sp>
+      <p:sp>
+        <p:nvSpPr>
           <p:cNvPr id="18" name="Text 16"/>
           <p:cNvSpPr txBox="1"/>
           <p:nvPr/>
         </p:nvSpPr>
         <p:spPr>
           <a:xfrm>
-            <a:off x="8386877" y="4480560"/>
-            <a:ext cx="3027578" cy="1417320"/>
+            <a:off x="822960" y="5349240"/>
+            <a:ext cx="4838548" cy="566928"/>
           </a:xfrm>
           <a:prstGeom prst="rect">
             <a:avLst/>
@@ -13611,28 +13605,203 @@
               <a:buNone/>
             </a:pPr>
             <a:r>
-              <a:rPr lang="en-US" sz="1000" b="1" spc="150" kern="0" dirty="0">
+              <a:rPr lang="en-US" sz="1100" b="1" i="1" dirty="0">
                 <a:solidFill>
                   <a:srgbClr val="EE2B7A"/>
                 </a:solidFill>
               </a:rPr>
-              <a:t>IN PRACTICE</a:t>
-            </a:r>
-            <a:endParaRPr lang="en-US" sz="1000" dirty="0"/>
-          </a:p>
-          <a:p>
+              <a:t>In practice:  </a:t>
+            </a:r>
             <a:pPr indent="0" marL="0">
               <a:buNone/>
             </a:pPr>
             <a:r>
+              <a:rPr lang="en-US" sz="1100" i="1" dirty="0">
+                <a:solidFill>
+                  <a:srgbClr val="3D3C3C"/>
+                </a:solidFill>
+              </a:rPr>
+              <a:t>The alternative alignment gained support because it built on HSRA's Business Case. Another partner's late, untested idea did not progress.</a:t>
+            </a:r>
+            <a:endParaRPr lang="en-US" sz="1100" dirty="0"/>
+          </a:p>
+        </p:txBody>
+      </p:sp>
+      <p:pic>
+        <p:nvPicPr>
+          <p:cNvPr id="19" name="Image 0" descr="grad_purple.png">    </p:cNvPr>
+          <p:cNvPicPr>
+            <a:picLocks noChangeAspect="1"/>
+          </p:cNvPicPr>
+          <p:nvPr/>
+        </p:nvPicPr>
+        <p:blipFill>
+          <a:blip r:embed="rId1"/>
+          <a:srcRect l="0" r="0" t="0" b="0"/>
+          <a:stretch/>
+        </p:blipFill>
+        <p:spPr>
+          <a:xfrm>
+            <a:off x="6255868" y="3886200"/>
+            <a:ext cx="5387188" cy="2148840"/>
+          </a:xfrm>
+          <a:prstGeom prst="rect">
+            <a:avLst/>
+          </a:prstGeom>
+        </p:spPr>
+      </p:pic>
+      <p:sp>
+        <p:nvSpPr>
+          <p:cNvPr id="20" name="Text 17"/>
+          <p:cNvSpPr txBox="1"/>
+          <p:nvPr/>
+        </p:nvSpPr>
+        <p:spPr>
+          <a:xfrm>
+            <a:off x="6530188" y="4069080"/>
+            <a:ext cx="640080" cy="548640"/>
+          </a:xfrm>
+          <a:prstGeom prst="rect">
+            <a:avLst/>
+          </a:prstGeom>
+          <a:noFill/>
+          <a:ln/>
+        </p:spPr>
+        <p:txBody>
+          <a:bodyPr wrap="square" lIns="0" tIns="0" rIns="0" bIns="0" rtlCol="0" anchor="ctr"/>
+          <a:lstStyle/>
+          <a:p>
+            <a:pPr indent="0" marL="0">
+              <a:buNone/>
+            </a:pPr>
+            <a:r>
+              <a:rPr lang="en-US" sz="2800" b="1" dirty="0">
+                <a:solidFill>
+                  <a:srgbClr val="FFFFFF"/>
+                </a:solidFill>
+              </a:rPr>
+              <a:t>04</a:t>
+            </a:r>
+            <a:endParaRPr lang="en-US" sz="2800" dirty="0"/>
+          </a:p>
+        </p:txBody>
+      </p:sp>
+      <p:sp>
+        <p:nvSpPr>
+          <p:cNvPr id="21" name="Text 18"/>
+          <p:cNvSpPr txBox="1"/>
+          <p:nvPr/>
+        </p:nvSpPr>
+        <p:spPr>
+          <a:xfrm>
+            <a:off x="7151980" y="4069080"/>
+            <a:ext cx="4244188" cy="548640"/>
+          </a:xfrm>
+          <a:prstGeom prst="rect">
+            <a:avLst/>
+          </a:prstGeom>
+          <a:noFill/>
+          <a:ln/>
+        </p:spPr>
+        <p:txBody>
+          <a:bodyPr wrap="square" lIns="0" tIns="0" rIns="0" bIns="0" rtlCol="0" anchor="ctr"/>
+          <a:lstStyle/>
+          <a:p>
+            <a:pPr indent="0" marL="0">
+              <a:buNone/>
+            </a:pPr>
+            <a:r>
+              <a:rPr lang="en-US" sz="1600" b="1" dirty="0">
+                <a:solidFill>
+                  <a:srgbClr val="FFFFFF"/>
+                </a:solidFill>
+              </a:rPr>
+              <a:t>Our secret sauce: HSRA at the centre</a:t>
+            </a:r>
+            <a:endParaRPr lang="en-US" sz="1600" dirty="0"/>
+          </a:p>
+        </p:txBody>
+      </p:sp>
+      <p:sp>
+        <p:nvSpPr>
+          <p:cNvPr id="22" name="Text 19"/>
+          <p:cNvSpPr txBox="1"/>
+          <p:nvPr/>
+        </p:nvSpPr>
+        <p:spPr>
+          <a:xfrm>
+            <a:off x="6530188" y="4690872"/>
+            <a:ext cx="4838548" cy="640080"/>
+          </a:xfrm>
+          <a:prstGeom prst="rect">
+            <a:avLst/>
+          </a:prstGeom>
+          <a:noFill/>
+          <a:ln/>
+        </p:spPr>
+        <p:txBody>
+          <a:bodyPr wrap="square" lIns="0" tIns="0" rIns="0" bIns="0" rtlCol="0" anchor="t"/>
+          <a:lstStyle/>
+          <a:p>
+            <a:pPr indent="0" marL="0">
+              <a:buNone/>
+            </a:pPr>
+            <a:r>
               <a:rPr lang="en-US" sz="1200" dirty="0">
                 <a:solidFill>
-                  <a:srgbClr val="3D3C3C"/>
-                </a:solidFill>
-              </a:rPr>
-              <a:t>The alternative alignment gained support because it built on HSRA's Business Case. Another partner's late, untested idea did not progress.</a:t>
-            </a:r>
-            <a:endParaRPr lang="en-US" sz="1000" dirty="0"/>
+                  <a:srgbClr val="FFFFFF"/>
+                </a:solidFill>
+              </a:rPr>
+              <a:t>Customer centricity sets GoFar apart. Every message starts with what HSRA needs, and we will keep building on it in the ECI.</a:t>
+            </a:r>
+            <a:endParaRPr lang="en-US" sz="1200" dirty="0"/>
+          </a:p>
+        </p:txBody>
+      </p:sp>
+      <p:sp>
+        <p:nvSpPr>
+          <p:cNvPr id="23" name="Text 20"/>
+          <p:cNvSpPr txBox="1"/>
+          <p:nvPr/>
+        </p:nvSpPr>
+        <p:spPr>
+          <a:xfrm>
+            <a:off x="6530188" y="5349240"/>
+            <a:ext cx="4838548" cy="566928"/>
+          </a:xfrm>
+          <a:prstGeom prst="rect">
+            <a:avLst/>
+          </a:prstGeom>
+          <a:noFill/>
+          <a:ln/>
+        </p:spPr>
+        <p:txBody>
+          <a:bodyPr wrap="square" lIns="0" tIns="0" rIns="0" bIns="0" rtlCol="0" anchor="t"/>
+          <a:lstStyle/>
+          <a:p>
+            <a:pPr indent="0" marL="0">
+              <a:buNone/>
+            </a:pPr>
+            <a:r>
+              <a:rPr lang="en-US" sz="1100" b="1" i="1" dirty="0">
+                <a:solidFill>
+                  <a:srgbClr val="FFFFFF"/>
+                </a:solidFill>
+              </a:rPr>
+              <a:t>In practice:  </a:t>
+            </a:r>
+            <a:pPr indent="0" marL="0">
+              <a:buNone/>
+            </a:pPr>
+            <a:r>
+              <a:rPr lang="en-US" sz="1100" i="1" dirty="0">
+                <a:solidFill>
+                  <a:srgbClr val="FFFFFF"/>
+                </a:solidFill>
+              </a:rPr>
+              <a:t>By linking every point to HSRA's benefit, the alternative alignment became known as the GoFar alignment and gained other partners' support.</a:t>
+            </a:r>
+            <a:endParaRPr lang="en-US" sz="1100" dirty="0"/>
           </a:p>
         </p:txBody>
       </p:sp>

</xml_diff>